<commit_message>
fix: TO BE duplicato risolto, logo azienda, totale sedi, scenari col I/J/K
</commit_message>
<xml_diff>
--- a/source/public/Envizi-Report-template.pptx
+++ b/source/public/Envizi-Report-template.pptx
@@ -14,7 +14,6 @@
     <p:sldId id="259" r:id="rId5"/>
     <p:sldId id="260" r:id="rId6"/>
     <p:sldId id="261" r:id="rId7"/>
-    <p:sldId id="262" r:id="rId8"/>
   </p:sldIdLst>
   <p:sldSz cx="12192000" cy="6858000"/>
   <p:notesSz cx="6858000" cy="9144000"/>
@@ -9179,2186 +9178,6 @@
 </p:sld>
 </file>
 
-<file path=ppt/slides/slide7.xml><?xml version="1.0" encoding="utf-8"?>
-<p:sld xmlns:a="http://schemas.openxmlformats.org/drawingml/2006/main" xmlns:r="http://schemas.openxmlformats.org/officeDocument/2006/relationships" xmlns:p="http://schemas.openxmlformats.org/presentationml/2006/main">
-  <p:cSld>
-    <p:spTree>
-      <p:nvGrpSpPr>
-        <p:cNvPr id="1" name=""/>
-        <p:cNvGrpSpPr/>
-        <p:nvPr/>
-      </p:nvGrpSpPr>
-      <p:grpSpPr>
-        <a:xfrm>
-          <a:off x="0" y="0"/>
-          <a:ext cx="0" cy="0"/>
-          <a:chOff x="0" y="0"/>
-          <a:chExt cx="0" cy="0"/>
-        </a:xfrm>
-      </p:grpSpPr>
-      <p:sp>
-        <p:nvSpPr>
-          <p:cNvPr id="43" name="Rettangolo 42">
-            <a:extLst>
-              <a:ext uri="{FF2B5EF4-FFF2-40B4-BE49-F238E27FC236}">
-                <a16:creationId xmlns:a16="http://schemas.microsoft.com/office/drawing/2014/main" id="{9CD23942-A7E8-47ED-98E4-0882DCDA4474}"/>
-              </a:ext>
-            </a:extLst>
-          </p:cNvPr>
-          <p:cNvSpPr>
-            <a:spLocks noGrp="1"/>
-          </p:cNvSpPr>
-          <p:nvPr/>
-        </p:nvSpPr>
-        <p:spPr>
-          <a:xfrm>
-            <a:off x="0" y="0"/>
-            <a:ext cx="12192000" cy="6858000"/>
-          </a:xfrm>
-          <a:prstGeom prst="rect">
-            <a:avLst/>
-          </a:prstGeom>
-          <a:solidFill>
-            <a:srgbClr val="FFFFFF"/>
-          </a:solidFill>
-          <a:ln w="0">
-            <a:solidFill>
-              <a:srgbClr val="FFFFFF"/>
-            </a:solidFill>
-          </a:ln>
-        </p:spPr>
-        <p:txBody>
-          <a:bodyPr/>
-          <a:lstStyle/>
-          <a:p>
-            <a:endParaRPr lang="it-IT"/>
-          </a:p>
-        </p:txBody>
-      </p:sp>
-      <p:sp>
-        <p:nvSpPr>
-          <p:cNvPr id="2" name="Rettangolo 1">
-            <a:extLst>
-              <a:ext uri="{FF2B5EF4-FFF2-40B4-BE49-F238E27FC236}">
-                <a16:creationId xmlns:a16="http://schemas.microsoft.com/office/drawing/2014/main" id="{31A595D6-3BF7-4A77-B464-4650BA028BDE}"/>
-              </a:ext>
-            </a:extLst>
-          </p:cNvPr>
-          <p:cNvSpPr>
-            <a:spLocks noGrp="1"/>
-          </p:cNvSpPr>
-          <p:nvPr/>
-        </p:nvSpPr>
-        <p:spPr>
-          <a:xfrm>
-            <a:off x="419100" y="285750"/>
-            <a:ext cx="9334500" cy="476250"/>
-          </a:xfrm>
-          <a:prstGeom prst="rect">
-            <a:avLst/>
-          </a:prstGeom>
-          <a:noFill/>
-          <a:ln w="0">
-            <a:noFill/>
-          </a:ln>
-        </p:spPr>
-        <p:txBody>
-          <a:bodyPr>
-            <a:normAutofit/>
-          </a:bodyPr>
-          <a:lstStyle/>
-          <a:p>
-            <a:pPr algn="l">
-              <a:defRPr sz="1875" b="1">
-                <a:solidFill>
-                  <a:srgbClr val="1D776B"/>
-                </a:solidFill>
-                <a:latin typeface="Calibri"/>
-                <a:ea typeface="Calibri"/>
-                <a:cs typeface="Calibri"/>
-              </a:defRPr>
-            </a:pPr>
-            <a:r>
-              <a:rPr sz="1875" b="1" dirty="0">
-                <a:solidFill>
-                  <a:srgbClr val="1D776B"/>
-                </a:solidFill>
-                <a:latin typeface="Calibri"/>
-                <a:ea typeface="Calibri"/>
-                <a:cs typeface="Calibri"/>
-              </a:rPr>
-              <a:t>Le </a:t>
-            </a:r>
-            <a:r>
-              <a:rPr sz="1875" b="1" dirty="0" err="1">
-                <a:solidFill>
-                  <a:srgbClr val="1D776B"/>
-                </a:solidFill>
-                <a:latin typeface="Calibri"/>
-                <a:ea typeface="Calibri"/>
-                <a:cs typeface="Calibri"/>
-              </a:rPr>
-              <a:t>prossime</a:t>
-            </a:r>
-            <a:r>
-              <a:rPr sz="1875" b="1" dirty="0">
-                <a:solidFill>
-                  <a:srgbClr val="1D776B"/>
-                </a:solidFill>
-                <a:latin typeface="Calibri"/>
-                <a:ea typeface="Calibri"/>
-                <a:cs typeface="Calibri"/>
-              </a:rPr>
-              <a:t> </a:t>
-            </a:r>
-            <a:r>
-              <a:rPr sz="1875" b="1" dirty="0" err="1">
-                <a:solidFill>
-                  <a:srgbClr val="1D776B"/>
-                </a:solidFill>
-                <a:latin typeface="Calibri"/>
-                <a:ea typeface="Calibri"/>
-                <a:cs typeface="Calibri"/>
-              </a:rPr>
-              <a:t>sfide</a:t>
-            </a:r>
-            <a:r>
-              <a:rPr sz="1875" b="1" dirty="0">
-                <a:solidFill>
-                  <a:srgbClr val="1D776B"/>
-                </a:solidFill>
-                <a:latin typeface="Calibri"/>
-                <a:ea typeface="Calibri"/>
-                <a:cs typeface="Calibri"/>
-              </a:rPr>
-              <a:t> da </a:t>
-            </a:r>
-            <a:r>
-              <a:rPr sz="1875" b="1" dirty="0" err="1">
-                <a:solidFill>
-                  <a:srgbClr val="1D776B"/>
-                </a:solidFill>
-                <a:latin typeface="Calibri"/>
-                <a:ea typeface="Calibri"/>
-                <a:cs typeface="Calibri"/>
-              </a:rPr>
-              <a:t>valutare</a:t>
-            </a:r>
-            <a:endParaRPr sz="1875" b="1" dirty="0">
-              <a:solidFill>
-                <a:srgbClr val="1D776B"/>
-              </a:solidFill>
-              <a:latin typeface="Calibri"/>
-              <a:ea typeface="Calibri"/>
-              <a:cs typeface="Calibri"/>
-            </a:endParaRPr>
-          </a:p>
-        </p:txBody>
-      </p:sp>
-      <p:sp>
-        <p:nvSpPr>
-          <p:cNvPr id="3" name="Rettangolo 2">
-            <a:extLst>
-              <a:ext uri="{FF2B5EF4-FFF2-40B4-BE49-F238E27FC236}">
-                <a16:creationId xmlns:a16="http://schemas.microsoft.com/office/drawing/2014/main" id="{E1BF97F8-7BF8-4022-AEDE-4DA2874E10BF}"/>
-              </a:ext>
-            </a:extLst>
-          </p:cNvPr>
-          <p:cNvSpPr>
-            <a:spLocks noGrp="1"/>
-          </p:cNvSpPr>
-          <p:nvPr/>
-        </p:nvSpPr>
-        <p:spPr>
-          <a:xfrm>
-            <a:off x="419100" y="714375"/>
-            <a:ext cx="9810750" cy="333375"/>
-          </a:xfrm>
-          <a:prstGeom prst="rect">
-            <a:avLst/>
-          </a:prstGeom>
-          <a:noFill/>
-          <a:ln w="0">
-            <a:noFill/>
-          </a:ln>
-        </p:spPr>
-        <p:txBody>
-          <a:bodyPr>
-            <a:normAutofit/>
-          </a:bodyPr>
-          <a:lstStyle/>
-          <a:p>
-            <a:pPr algn="l">
-              <a:defRPr sz="1200" b="0">
-                <a:solidFill>
-                  <a:srgbClr val="4D6D67"/>
-                </a:solidFill>
-                <a:latin typeface="Calibri"/>
-                <a:ea typeface="Calibri"/>
-                <a:cs typeface="Calibri"/>
-              </a:defRPr>
-            </a:pPr>
-            <a:r>
-              <a:rPr sz="1200" b="0">
-                <a:solidFill>
-                  <a:srgbClr val="4D6D67"/>
-                </a:solidFill>
-                <a:latin typeface="Calibri"/>
-                <a:ea typeface="Calibri"/>
-                <a:cs typeface="Calibri"/>
-              </a:rPr>
-              <a:t>Aree proposte in base alle risposte e alle criticità dichiarate da Erica</a:t>
-            </a:r>
-          </a:p>
-        </p:txBody>
-      </p:sp>
-      <p:pic>
-        <p:nvPicPr>
-          <p:cNvPr id="46" name="Immagine 45"/>
-          <p:cNvPicPr>
-            <a:picLocks noChangeAspect="1"/>
-          </p:cNvPicPr>
-          <p:nvPr/>
-        </p:nvPicPr>
-        <p:blipFill>
-          <a:blip r:embed="rId3"/>
-          <a:stretch/>
-        </p:blipFill>
-        <p:spPr>
-          <a:xfrm>
-            <a:off x="10191750" y="228600"/>
-            <a:ext cx="1571625" cy="523875"/>
-          </a:xfrm>
-          <a:prstGeom prst="rect">
-            <a:avLst/>
-          </a:prstGeom>
-        </p:spPr>
-      </p:pic>
-      <p:sp>
-        <p:nvSpPr>
-          <p:cNvPr id="5" name="Rettangolo con angoli arrotondati 4">
-            <a:extLst>
-              <a:ext uri="{FF2B5EF4-FFF2-40B4-BE49-F238E27FC236}">
-                <a16:creationId xmlns:a16="http://schemas.microsoft.com/office/drawing/2014/main" id="{F17ADCB9-C82F-40EA-A2A0-F51AFF7D34A4}"/>
-              </a:ext>
-            </a:extLst>
-          </p:cNvPr>
-          <p:cNvSpPr>
-            <a:spLocks noGrp="1"/>
-          </p:cNvSpPr>
-          <p:nvPr/>
-        </p:nvSpPr>
-        <p:spPr>
-          <a:xfrm>
-            <a:off x="514350" y="1219200"/>
-            <a:ext cx="5448300" cy="1028700"/>
-          </a:xfrm>
-          <a:prstGeom prst="roundRect">
-            <a:avLst>
-              <a:gd name="adj" fmla="val 12963"/>
-            </a:avLst>
-          </a:prstGeom>
-          <a:solidFill>
-            <a:srgbClr val="FFFFFF"/>
-          </a:solidFill>
-          <a:ln w="9525">
-            <a:solidFill>
-              <a:srgbClr val="C8DBD5"/>
-            </a:solidFill>
-          </a:ln>
-        </p:spPr>
-        <p:txBody>
-          <a:bodyPr/>
-          <a:lstStyle/>
-          <a:p>
-            <a:endParaRPr lang="it-IT"/>
-          </a:p>
-        </p:txBody>
-      </p:sp>
-      <p:sp>
-        <p:nvSpPr>
-          <p:cNvPr id="6" name="Ovale 5">
-            <a:extLst>
-              <a:ext uri="{FF2B5EF4-FFF2-40B4-BE49-F238E27FC236}">
-                <a16:creationId xmlns:a16="http://schemas.microsoft.com/office/drawing/2014/main" id="{0303F424-3828-409E-8B3D-B446FE681C49}"/>
-              </a:ext>
-            </a:extLst>
-          </p:cNvPr>
-          <p:cNvSpPr>
-            <a:spLocks noGrp="1"/>
-          </p:cNvSpPr>
-          <p:nvPr/>
-        </p:nvSpPr>
-        <p:spPr>
-          <a:xfrm>
-            <a:off x="704850" y="1438275"/>
-            <a:ext cx="514350" cy="514350"/>
-          </a:xfrm>
-          <a:prstGeom prst="ellipse">
-            <a:avLst/>
-          </a:prstGeom>
-          <a:solidFill>
-            <a:srgbClr val="42CBB2"/>
-          </a:solidFill>
-          <a:ln w="0">
-            <a:solidFill>
-              <a:srgbClr val="42CBB2"/>
-            </a:solidFill>
-          </a:ln>
-        </p:spPr>
-        <p:txBody>
-          <a:bodyPr/>
-          <a:lstStyle/>
-          <a:p>
-            <a:endParaRPr lang="it-IT"/>
-          </a:p>
-        </p:txBody>
-      </p:sp>
-      <p:sp>
-        <p:nvSpPr>
-          <p:cNvPr id="7" name="Rettangolo 6">
-            <a:extLst>
-              <a:ext uri="{FF2B5EF4-FFF2-40B4-BE49-F238E27FC236}">
-                <a16:creationId xmlns:a16="http://schemas.microsoft.com/office/drawing/2014/main" id="{A0D90B4F-4560-4E18-80C5-FFE11107822B}"/>
-              </a:ext>
-            </a:extLst>
-          </p:cNvPr>
-          <p:cNvSpPr>
-            <a:spLocks noGrp="1"/>
-          </p:cNvSpPr>
-          <p:nvPr/>
-        </p:nvSpPr>
-        <p:spPr>
-          <a:xfrm>
-            <a:off x="771525" y="1552575"/>
-            <a:ext cx="381000" cy="238125"/>
-          </a:xfrm>
-          <a:prstGeom prst="rect">
-            <a:avLst/>
-          </a:prstGeom>
-          <a:noFill/>
-          <a:ln w="0">
-            <a:noFill/>
-          </a:ln>
-        </p:spPr>
-        <p:txBody>
-          <a:bodyPr>
-            <a:normAutofit fontScale="80208"/>
-          </a:bodyPr>
-          <a:lstStyle/>
-          <a:p>
-            <a:pPr algn="ctr">
-              <a:defRPr sz="1200" b="1">
-                <a:solidFill>
-                  <a:srgbClr val="FFFFFF"/>
-                </a:solidFill>
-                <a:latin typeface="Calibri"/>
-                <a:ea typeface="Calibri"/>
-                <a:cs typeface="Calibri"/>
-              </a:defRPr>
-            </a:pPr>
-            <a:r>
-              <a:rPr sz="1200" b="1">
-                <a:solidFill>
-                  <a:srgbClr val="FFFFFF"/>
-                </a:solidFill>
-                <a:latin typeface="Calibri"/>
-                <a:ea typeface="Calibri"/>
-                <a:cs typeface="Calibri"/>
-              </a:rPr>
-              <a:t>01</a:t>
-            </a:r>
-          </a:p>
-        </p:txBody>
-      </p:sp>
-      <p:sp>
-        <p:nvSpPr>
-          <p:cNvPr id="8" name="Rettangolo 7">
-            <a:extLst>
-              <a:ext uri="{FF2B5EF4-FFF2-40B4-BE49-F238E27FC236}">
-                <a16:creationId xmlns:a16="http://schemas.microsoft.com/office/drawing/2014/main" id="{8A06099F-C4EA-456D-9AE2-DE79CC801448}"/>
-              </a:ext>
-            </a:extLst>
-          </p:cNvPr>
-          <p:cNvSpPr>
-            <a:spLocks noGrp="1"/>
-          </p:cNvSpPr>
-          <p:nvPr/>
-        </p:nvSpPr>
-        <p:spPr>
-          <a:xfrm>
-            <a:off x="1409700" y="1381125"/>
-            <a:ext cx="4095750" cy="266700"/>
-          </a:xfrm>
-          <a:prstGeom prst="rect">
-            <a:avLst/>
-          </a:prstGeom>
-          <a:noFill/>
-          <a:ln w="0">
-            <a:noFill/>
-          </a:ln>
-        </p:spPr>
-        <p:txBody>
-          <a:bodyPr>
-            <a:normAutofit fontScale="85185"/>
-          </a:bodyPr>
-          <a:lstStyle/>
-          <a:p>
-            <a:pPr algn="l">
-              <a:defRPr sz="1350" b="1">
-                <a:solidFill>
-                  <a:srgbClr val="062D29"/>
-                </a:solidFill>
-                <a:latin typeface="Calibri"/>
-                <a:ea typeface="Calibri"/>
-                <a:cs typeface="Calibri"/>
-              </a:defRPr>
-            </a:pPr>
-            <a:r>
-              <a:rPr sz="1350" b="1">
-                <a:solidFill>
-                  <a:srgbClr val="062D29"/>
-                </a:solidFill>
-                <a:latin typeface="Calibri"/>
-                <a:ea typeface="Calibri"/>
-                <a:cs typeface="Calibri"/>
-              </a:rPr>
-              <a:t>Fabbrica dei dati</a:t>
-            </a:r>
-          </a:p>
-        </p:txBody>
-      </p:sp>
-      <p:sp>
-        <p:nvSpPr>
-          <p:cNvPr id="9" name="Rettangolo 8">
-            <a:extLst>
-              <a:ext uri="{FF2B5EF4-FFF2-40B4-BE49-F238E27FC236}">
-                <a16:creationId xmlns:a16="http://schemas.microsoft.com/office/drawing/2014/main" id="{A9EE5354-FAA5-43B3-839F-B10A26BB8488}"/>
-              </a:ext>
-            </a:extLst>
-          </p:cNvPr>
-          <p:cNvSpPr>
-            <a:spLocks noGrp="1"/>
-          </p:cNvSpPr>
-          <p:nvPr/>
-        </p:nvSpPr>
-        <p:spPr>
-          <a:xfrm>
-            <a:off x="1409700" y="1695450"/>
-            <a:ext cx="4191000" cy="428625"/>
-          </a:xfrm>
-          <a:prstGeom prst="rect">
-            <a:avLst/>
-          </a:prstGeom>
-          <a:noFill/>
-          <a:ln w="0">
-            <a:noFill/>
-          </a:ln>
-        </p:spPr>
-        <p:txBody>
-          <a:bodyPr>
-            <a:normAutofit/>
-          </a:bodyPr>
-          <a:lstStyle/>
-          <a:p>
-            <a:pPr algn="l">
-              <a:defRPr sz="1050" b="0">
-                <a:solidFill>
-                  <a:srgbClr val="4F6E67"/>
-                </a:solidFill>
-                <a:latin typeface="Calibri"/>
-                <a:ea typeface="Calibri"/>
-                <a:cs typeface="Calibri"/>
-              </a:defRPr>
-            </a:pPr>
-            <a:r>
-              <a:rPr sz="1050" b="0">
-                <a:solidFill>
-                  <a:srgbClr val="4F6E67"/>
-                </a:solidFill>
-                <a:latin typeface="Calibri"/>
-                <a:ea typeface="Calibri"/>
-                <a:cs typeface="Calibri"/>
-              </a:rPr>
-              <a:t>Readiness bassa; audit trail e completezza sono le esigenze con priorità più alta.</a:t>
-            </a:r>
-          </a:p>
-        </p:txBody>
-      </p:sp>
-      <p:sp>
-        <p:nvSpPr>
-          <p:cNvPr id="10" name="Rettangolo con angoli arrotondati 9">
-            <a:extLst>
-              <a:ext uri="{FF2B5EF4-FFF2-40B4-BE49-F238E27FC236}">
-                <a16:creationId xmlns:a16="http://schemas.microsoft.com/office/drawing/2014/main" id="{318ADF4D-CC5B-45B4-ABE0-678F25A0C768}"/>
-              </a:ext>
-            </a:extLst>
-          </p:cNvPr>
-          <p:cNvSpPr>
-            <a:spLocks noGrp="1"/>
-          </p:cNvSpPr>
-          <p:nvPr/>
-        </p:nvSpPr>
-        <p:spPr>
-          <a:xfrm>
-            <a:off x="514350" y="2438400"/>
-            <a:ext cx="5448300" cy="1028700"/>
-          </a:xfrm>
-          <a:prstGeom prst="roundRect">
-            <a:avLst>
-              <a:gd name="adj" fmla="val 12963"/>
-            </a:avLst>
-          </a:prstGeom>
-          <a:solidFill>
-            <a:srgbClr val="FFFFFF"/>
-          </a:solidFill>
-          <a:ln w="9525">
-            <a:solidFill>
-              <a:srgbClr val="C8DBD5"/>
-            </a:solidFill>
-          </a:ln>
-        </p:spPr>
-        <p:txBody>
-          <a:bodyPr/>
-          <a:lstStyle/>
-          <a:p>
-            <a:endParaRPr lang="it-IT"/>
-          </a:p>
-        </p:txBody>
-      </p:sp>
-      <p:sp>
-        <p:nvSpPr>
-          <p:cNvPr id="11" name="Ovale 10">
-            <a:extLst>
-              <a:ext uri="{FF2B5EF4-FFF2-40B4-BE49-F238E27FC236}">
-                <a16:creationId xmlns:a16="http://schemas.microsoft.com/office/drawing/2014/main" id="{4CB47445-96E0-4B2F-A908-2303A0573326}"/>
-              </a:ext>
-            </a:extLst>
-          </p:cNvPr>
-          <p:cNvSpPr>
-            <a:spLocks noGrp="1"/>
-          </p:cNvSpPr>
-          <p:nvPr/>
-        </p:nvSpPr>
-        <p:spPr>
-          <a:xfrm>
-            <a:off x="704850" y="2657475"/>
-            <a:ext cx="514350" cy="514350"/>
-          </a:xfrm>
-          <a:prstGeom prst="ellipse">
-            <a:avLst/>
-          </a:prstGeom>
-          <a:solidFill>
-            <a:srgbClr val="87BDD1"/>
-          </a:solidFill>
-          <a:ln w="0">
-            <a:solidFill>
-              <a:srgbClr val="87BDD1"/>
-            </a:solidFill>
-          </a:ln>
-        </p:spPr>
-        <p:txBody>
-          <a:bodyPr/>
-          <a:lstStyle/>
-          <a:p>
-            <a:endParaRPr lang="it-IT"/>
-          </a:p>
-        </p:txBody>
-      </p:sp>
-      <p:sp>
-        <p:nvSpPr>
-          <p:cNvPr id="12" name="Rettangolo 11">
-            <a:extLst>
-              <a:ext uri="{FF2B5EF4-FFF2-40B4-BE49-F238E27FC236}">
-                <a16:creationId xmlns:a16="http://schemas.microsoft.com/office/drawing/2014/main" id="{F6A86269-A2BD-4554-8906-3D2ACB0617FF}"/>
-              </a:ext>
-            </a:extLst>
-          </p:cNvPr>
-          <p:cNvSpPr>
-            <a:spLocks noGrp="1"/>
-          </p:cNvSpPr>
-          <p:nvPr/>
-        </p:nvSpPr>
-        <p:spPr>
-          <a:xfrm>
-            <a:off x="771525" y="2771775"/>
-            <a:ext cx="381000" cy="238125"/>
-          </a:xfrm>
-          <a:prstGeom prst="rect">
-            <a:avLst/>
-          </a:prstGeom>
-          <a:noFill/>
-          <a:ln w="0">
-            <a:noFill/>
-          </a:ln>
-        </p:spPr>
-        <p:txBody>
-          <a:bodyPr>
-            <a:normAutofit fontScale="80208"/>
-          </a:bodyPr>
-          <a:lstStyle/>
-          <a:p>
-            <a:pPr algn="ctr">
-              <a:defRPr sz="1200" b="1">
-                <a:solidFill>
-                  <a:srgbClr val="FFFFFF"/>
-                </a:solidFill>
-                <a:latin typeface="Calibri"/>
-                <a:ea typeface="Calibri"/>
-                <a:cs typeface="Calibri"/>
-              </a:defRPr>
-            </a:pPr>
-            <a:r>
-              <a:rPr sz="1200" b="1">
-                <a:solidFill>
-                  <a:srgbClr val="FFFFFF"/>
-                </a:solidFill>
-                <a:latin typeface="Calibri"/>
-                <a:ea typeface="Calibri"/>
-                <a:cs typeface="Calibri"/>
-              </a:rPr>
-              <a:t>02</a:t>
-            </a:r>
-          </a:p>
-        </p:txBody>
-      </p:sp>
-      <p:sp>
-        <p:nvSpPr>
-          <p:cNvPr id="13" name="Rettangolo 12">
-            <a:extLst>
-              <a:ext uri="{FF2B5EF4-FFF2-40B4-BE49-F238E27FC236}">
-                <a16:creationId xmlns:a16="http://schemas.microsoft.com/office/drawing/2014/main" id="{23DFEE07-10E2-4779-B2A5-E947EECD176F}"/>
-              </a:ext>
-            </a:extLst>
-          </p:cNvPr>
-          <p:cNvSpPr>
-            <a:spLocks noGrp="1"/>
-          </p:cNvSpPr>
-          <p:nvPr/>
-        </p:nvSpPr>
-        <p:spPr>
-          <a:xfrm>
-            <a:off x="1409700" y="2600325"/>
-            <a:ext cx="4095750" cy="266700"/>
-          </a:xfrm>
-          <a:prstGeom prst="rect">
-            <a:avLst/>
-          </a:prstGeom>
-          <a:noFill/>
-          <a:ln w="0">
-            <a:noFill/>
-          </a:ln>
-        </p:spPr>
-        <p:txBody>
-          <a:bodyPr>
-            <a:normAutofit fontScale="85185"/>
-          </a:bodyPr>
-          <a:lstStyle/>
-          <a:p>
-            <a:pPr algn="l">
-              <a:defRPr sz="1350" b="1">
-                <a:solidFill>
-                  <a:srgbClr val="062D29"/>
-                </a:solidFill>
-                <a:latin typeface="Calibri"/>
-                <a:ea typeface="Calibri"/>
-                <a:cs typeface="Calibri"/>
-              </a:defRPr>
-            </a:pPr>
-            <a:r>
-              <a:rPr sz="1350" b="1">
-                <a:solidFill>
-                  <a:srgbClr val="062D29"/>
-                </a:solidFill>
-                <a:latin typeface="Calibri"/>
-                <a:ea typeface="Calibri"/>
-                <a:cs typeface="Calibri"/>
-              </a:rPr>
-              <a:t>Scope 1 e 2</a:t>
-            </a:r>
-          </a:p>
-        </p:txBody>
-      </p:sp>
-      <p:sp>
-        <p:nvSpPr>
-          <p:cNvPr id="14" name="Rettangolo 13">
-            <a:extLst>
-              <a:ext uri="{FF2B5EF4-FFF2-40B4-BE49-F238E27FC236}">
-                <a16:creationId xmlns:a16="http://schemas.microsoft.com/office/drawing/2014/main" id="{D3CDB1C2-0296-48B4-939D-87EC9B69FFF9}"/>
-              </a:ext>
-            </a:extLst>
-          </p:cNvPr>
-          <p:cNvSpPr>
-            <a:spLocks noGrp="1"/>
-          </p:cNvSpPr>
-          <p:nvPr/>
-        </p:nvSpPr>
-        <p:spPr>
-          <a:xfrm>
-            <a:off x="1409700" y="2914650"/>
-            <a:ext cx="4191000" cy="428625"/>
-          </a:xfrm>
-          <a:prstGeom prst="rect">
-            <a:avLst/>
-          </a:prstGeom>
-          <a:noFill/>
-          <a:ln w="0">
-            <a:noFill/>
-          </a:ln>
-        </p:spPr>
-        <p:txBody>
-          <a:bodyPr>
-            <a:normAutofit/>
-          </a:bodyPr>
-          <a:lstStyle/>
-          <a:p>
-            <a:pPr algn="l">
-              <a:defRPr sz="1050" b="0">
-                <a:solidFill>
-                  <a:srgbClr val="4F6E67"/>
-                </a:solidFill>
-                <a:latin typeface="Calibri"/>
-                <a:ea typeface="Calibri"/>
-                <a:cs typeface="Calibri"/>
-              </a:defRPr>
-            </a:pPr>
-            <a:r>
-              <a:rPr sz="1050" b="0">
-                <a:solidFill>
-                  <a:srgbClr val="4F6E67"/>
-                </a:solidFill>
-                <a:latin typeface="Calibri"/>
-                <a:ea typeface="Calibri"/>
-                <a:cs typeface="Calibri"/>
-              </a:rPr>
-              <a:t>Manca una baseline affidabile per sito che colleghi consumi, costi e produzione.</a:t>
-            </a:r>
-          </a:p>
-        </p:txBody>
-      </p:sp>
-      <p:sp>
-        <p:nvSpPr>
-          <p:cNvPr id="15" name="Rettangolo con angoli arrotondati 14">
-            <a:extLst>
-              <a:ext uri="{FF2B5EF4-FFF2-40B4-BE49-F238E27FC236}">
-                <a16:creationId xmlns:a16="http://schemas.microsoft.com/office/drawing/2014/main" id="{AD442904-A889-488A-842D-201C830F38A2}"/>
-              </a:ext>
-            </a:extLst>
-          </p:cNvPr>
-          <p:cNvSpPr>
-            <a:spLocks noGrp="1"/>
-          </p:cNvSpPr>
-          <p:nvPr/>
-        </p:nvSpPr>
-        <p:spPr>
-          <a:xfrm>
-            <a:off x="514350" y="3657600"/>
-            <a:ext cx="5448300" cy="1028700"/>
-          </a:xfrm>
-          <a:prstGeom prst="roundRect">
-            <a:avLst>
-              <a:gd name="adj" fmla="val 12963"/>
-            </a:avLst>
-          </a:prstGeom>
-          <a:solidFill>
-            <a:srgbClr val="FFFFFF"/>
-          </a:solidFill>
-          <a:ln w="9525">
-            <a:solidFill>
-              <a:srgbClr val="C8DBD5"/>
-            </a:solidFill>
-          </a:ln>
-        </p:spPr>
-        <p:txBody>
-          <a:bodyPr/>
-          <a:lstStyle/>
-          <a:p>
-            <a:endParaRPr lang="it-IT"/>
-          </a:p>
-        </p:txBody>
-      </p:sp>
-      <p:sp>
-        <p:nvSpPr>
-          <p:cNvPr id="16" name="Ovale 15">
-            <a:extLst>
-              <a:ext uri="{FF2B5EF4-FFF2-40B4-BE49-F238E27FC236}">
-                <a16:creationId xmlns:a16="http://schemas.microsoft.com/office/drawing/2014/main" id="{E04A3147-A60F-4548-8FD8-653EB0CD29C1}"/>
-              </a:ext>
-            </a:extLst>
-          </p:cNvPr>
-          <p:cNvSpPr>
-            <a:spLocks noGrp="1"/>
-          </p:cNvSpPr>
-          <p:nvPr/>
-        </p:nvSpPr>
-        <p:spPr>
-          <a:xfrm>
-            <a:off x="704850" y="3876675"/>
-            <a:ext cx="514350" cy="514350"/>
-          </a:xfrm>
-          <a:prstGeom prst="ellipse">
-            <a:avLst/>
-          </a:prstGeom>
-          <a:solidFill>
-            <a:srgbClr val="8B6BB3"/>
-          </a:solidFill>
-          <a:ln w="0">
-            <a:solidFill>
-              <a:srgbClr val="8B6BB3"/>
-            </a:solidFill>
-          </a:ln>
-        </p:spPr>
-        <p:txBody>
-          <a:bodyPr/>
-          <a:lstStyle/>
-          <a:p>
-            <a:endParaRPr lang="it-IT"/>
-          </a:p>
-        </p:txBody>
-      </p:sp>
-      <p:sp>
-        <p:nvSpPr>
-          <p:cNvPr id="17" name="Rettangolo 16">
-            <a:extLst>
-              <a:ext uri="{FF2B5EF4-FFF2-40B4-BE49-F238E27FC236}">
-                <a16:creationId xmlns:a16="http://schemas.microsoft.com/office/drawing/2014/main" id="{CC37AEC6-F768-46B3-A740-EB315387C4C5}"/>
-              </a:ext>
-            </a:extLst>
-          </p:cNvPr>
-          <p:cNvSpPr>
-            <a:spLocks noGrp="1"/>
-          </p:cNvSpPr>
-          <p:nvPr/>
-        </p:nvSpPr>
-        <p:spPr>
-          <a:xfrm>
-            <a:off x="771525" y="3990975"/>
-            <a:ext cx="381000" cy="238125"/>
-          </a:xfrm>
-          <a:prstGeom prst="rect">
-            <a:avLst/>
-          </a:prstGeom>
-          <a:noFill/>
-          <a:ln w="0">
-            <a:noFill/>
-          </a:ln>
-        </p:spPr>
-        <p:txBody>
-          <a:bodyPr>
-            <a:normAutofit fontScale="80208"/>
-          </a:bodyPr>
-          <a:lstStyle/>
-          <a:p>
-            <a:pPr algn="ctr">
-              <a:defRPr sz="1200" b="1">
-                <a:solidFill>
-                  <a:srgbClr val="FFFFFF"/>
-                </a:solidFill>
-                <a:latin typeface="Calibri"/>
-                <a:ea typeface="Calibri"/>
-                <a:cs typeface="Calibri"/>
-              </a:defRPr>
-            </a:pPr>
-            <a:r>
-              <a:rPr sz="1200" b="1">
-                <a:solidFill>
-                  <a:srgbClr val="FFFFFF"/>
-                </a:solidFill>
-                <a:latin typeface="Calibri"/>
-                <a:ea typeface="Calibri"/>
-                <a:cs typeface="Calibri"/>
-              </a:rPr>
-              <a:t>03</a:t>
-            </a:r>
-          </a:p>
-        </p:txBody>
-      </p:sp>
-      <p:sp>
-        <p:nvSpPr>
-          <p:cNvPr id="18" name="Rettangolo 17">
-            <a:extLst>
-              <a:ext uri="{FF2B5EF4-FFF2-40B4-BE49-F238E27FC236}">
-                <a16:creationId xmlns:a16="http://schemas.microsoft.com/office/drawing/2014/main" id="{63352276-51B1-4B46-80BD-39607BA4E198}"/>
-              </a:ext>
-            </a:extLst>
-          </p:cNvPr>
-          <p:cNvSpPr>
-            <a:spLocks noGrp="1"/>
-          </p:cNvSpPr>
-          <p:nvPr/>
-        </p:nvSpPr>
-        <p:spPr>
-          <a:xfrm>
-            <a:off x="1409700" y="3819525"/>
-            <a:ext cx="4095750" cy="266700"/>
-          </a:xfrm>
-          <a:prstGeom prst="rect">
-            <a:avLst/>
-          </a:prstGeom>
-          <a:noFill/>
-          <a:ln w="0">
-            <a:noFill/>
-          </a:ln>
-        </p:spPr>
-        <p:txBody>
-          <a:bodyPr>
-            <a:normAutofit fontScale="85185"/>
-          </a:bodyPr>
-          <a:lstStyle/>
-          <a:p>
-            <a:pPr algn="l">
-              <a:defRPr sz="1350" b="1">
-                <a:solidFill>
-                  <a:srgbClr val="062D29"/>
-                </a:solidFill>
-                <a:latin typeface="Calibri"/>
-                <a:ea typeface="Calibri"/>
-                <a:cs typeface="Calibri"/>
-              </a:defRPr>
-            </a:pPr>
-            <a:r>
-              <a:rPr sz="1350" b="1">
-                <a:solidFill>
-                  <a:srgbClr val="062D29"/>
-                </a:solidFill>
-                <a:latin typeface="Calibri"/>
-                <a:ea typeface="Calibri"/>
-                <a:cs typeface="Calibri"/>
-              </a:rPr>
-              <a:t>Scope 3 reporting</a:t>
-            </a:r>
-          </a:p>
-        </p:txBody>
-      </p:sp>
-      <p:sp>
-        <p:nvSpPr>
-          <p:cNvPr id="19" name="Rettangolo 18">
-            <a:extLst>
-              <a:ext uri="{FF2B5EF4-FFF2-40B4-BE49-F238E27FC236}">
-                <a16:creationId xmlns:a16="http://schemas.microsoft.com/office/drawing/2014/main" id="{0073B83A-7D0B-4DB8-81BC-C32E72ED9AB2}"/>
-              </a:ext>
-            </a:extLst>
-          </p:cNvPr>
-          <p:cNvSpPr>
-            <a:spLocks noGrp="1"/>
-          </p:cNvSpPr>
-          <p:nvPr/>
-        </p:nvSpPr>
-        <p:spPr>
-          <a:xfrm>
-            <a:off x="1409700" y="4133850"/>
-            <a:ext cx="4191000" cy="428625"/>
-          </a:xfrm>
-          <a:prstGeom prst="rect">
-            <a:avLst/>
-          </a:prstGeom>
-          <a:noFill/>
-          <a:ln w="0">
-            <a:noFill/>
-          </a:ln>
-        </p:spPr>
-        <p:txBody>
-          <a:bodyPr>
-            <a:normAutofit/>
-          </a:bodyPr>
-          <a:lstStyle/>
-          <a:p>
-            <a:pPr algn="l">
-              <a:defRPr sz="1050" b="0">
-                <a:solidFill>
-                  <a:srgbClr val="4F6E67"/>
-                </a:solidFill>
-                <a:latin typeface="Calibri"/>
-                <a:ea typeface="Calibri"/>
-                <a:cs typeface="Calibri"/>
-              </a:defRPr>
-            </a:pPr>
-            <a:r>
-              <a:rPr sz="1050" b="0">
-                <a:solidFill>
-                  <a:srgbClr val="4F6E67"/>
-                </a:solidFill>
-                <a:latin typeface="Calibri"/>
-                <a:ea typeface="Calibri"/>
-                <a:cs typeface="Calibri"/>
-              </a:rPr>
-              <a:t>Le categorie 1 e 2 valgono il 65% dell’impronta; le stime attuali sono spend-based.</a:t>
-            </a:r>
-          </a:p>
-        </p:txBody>
-      </p:sp>
-      <p:sp>
-        <p:nvSpPr>
-          <p:cNvPr id="20" name="Rettangolo con angoli arrotondati 19">
-            <a:extLst>
-              <a:ext uri="{FF2B5EF4-FFF2-40B4-BE49-F238E27FC236}">
-                <a16:creationId xmlns:a16="http://schemas.microsoft.com/office/drawing/2014/main" id="{8CF94C94-574E-47E0-932D-15A36F78B6F8}"/>
-              </a:ext>
-            </a:extLst>
-          </p:cNvPr>
-          <p:cNvSpPr>
-            <a:spLocks noGrp="1"/>
-          </p:cNvSpPr>
-          <p:nvPr/>
-        </p:nvSpPr>
-        <p:spPr>
-          <a:xfrm>
-            <a:off x="514350" y="4876800"/>
-            <a:ext cx="5448300" cy="1028700"/>
-          </a:xfrm>
-          <a:prstGeom prst="roundRect">
-            <a:avLst>
-              <a:gd name="adj" fmla="val 12963"/>
-            </a:avLst>
-          </a:prstGeom>
-          <a:solidFill>
-            <a:srgbClr val="FFFFFF"/>
-          </a:solidFill>
-          <a:ln w="9525">
-            <a:solidFill>
-              <a:srgbClr val="C8DBD5"/>
-            </a:solidFill>
-          </a:ln>
-        </p:spPr>
-        <p:txBody>
-          <a:bodyPr/>
-          <a:lstStyle/>
-          <a:p>
-            <a:endParaRPr lang="it-IT"/>
-          </a:p>
-        </p:txBody>
-      </p:sp>
-      <p:sp>
-        <p:nvSpPr>
-          <p:cNvPr id="21" name="Ovale 20">
-            <a:extLst>
-              <a:ext uri="{FF2B5EF4-FFF2-40B4-BE49-F238E27FC236}">
-                <a16:creationId xmlns:a16="http://schemas.microsoft.com/office/drawing/2014/main" id="{0EBB4C09-A19B-498A-9BBE-80EFDBE8E768}"/>
-              </a:ext>
-            </a:extLst>
-          </p:cNvPr>
-          <p:cNvSpPr>
-            <a:spLocks noGrp="1"/>
-          </p:cNvSpPr>
-          <p:nvPr/>
-        </p:nvSpPr>
-        <p:spPr>
-          <a:xfrm>
-            <a:off x="704850" y="5095875"/>
-            <a:ext cx="514350" cy="514350"/>
-          </a:xfrm>
-          <a:prstGeom prst="ellipse">
-            <a:avLst/>
-          </a:prstGeom>
-          <a:solidFill>
-            <a:srgbClr val="1D776B"/>
-          </a:solidFill>
-          <a:ln w="0">
-            <a:solidFill>
-              <a:srgbClr val="1D776B"/>
-            </a:solidFill>
-          </a:ln>
-        </p:spPr>
-        <p:txBody>
-          <a:bodyPr/>
-          <a:lstStyle/>
-          <a:p>
-            <a:endParaRPr lang="it-IT"/>
-          </a:p>
-        </p:txBody>
-      </p:sp>
-      <p:sp>
-        <p:nvSpPr>
-          <p:cNvPr id="22" name="Rettangolo 21">
-            <a:extLst>
-              <a:ext uri="{FF2B5EF4-FFF2-40B4-BE49-F238E27FC236}">
-                <a16:creationId xmlns:a16="http://schemas.microsoft.com/office/drawing/2014/main" id="{8154E11C-6E60-45EF-B211-811C46BE4637}"/>
-              </a:ext>
-            </a:extLst>
-          </p:cNvPr>
-          <p:cNvSpPr>
-            <a:spLocks noGrp="1"/>
-          </p:cNvSpPr>
-          <p:nvPr/>
-        </p:nvSpPr>
-        <p:spPr>
-          <a:xfrm>
-            <a:off x="771525" y="5210175"/>
-            <a:ext cx="381000" cy="238125"/>
-          </a:xfrm>
-          <a:prstGeom prst="rect">
-            <a:avLst/>
-          </a:prstGeom>
-          <a:noFill/>
-          <a:ln w="0">
-            <a:noFill/>
-          </a:ln>
-        </p:spPr>
-        <p:txBody>
-          <a:bodyPr>
-            <a:normAutofit fontScale="80208"/>
-          </a:bodyPr>
-          <a:lstStyle/>
-          <a:p>
-            <a:pPr algn="ctr">
-              <a:defRPr sz="1200" b="1">
-                <a:solidFill>
-                  <a:srgbClr val="FFFFFF"/>
-                </a:solidFill>
-                <a:latin typeface="Calibri"/>
-                <a:ea typeface="Calibri"/>
-                <a:cs typeface="Calibri"/>
-              </a:defRPr>
-            </a:pPr>
-            <a:r>
-              <a:rPr sz="1200" b="1">
-                <a:solidFill>
-                  <a:srgbClr val="FFFFFF"/>
-                </a:solidFill>
-                <a:latin typeface="Calibri"/>
-                <a:ea typeface="Calibri"/>
-                <a:cs typeface="Calibri"/>
-              </a:rPr>
-              <a:t>04</a:t>
-            </a:r>
-          </a:p>
-        </p:txBody>
-      </p:sp>
-      <p:sp>
-        <p:nvSpPr>
-          <p:cNvPr id="23" name="Rettangolo 22">
-            <a:extLst>
-              <a:ext uri="{FF2B5EF4-FFF2-40B4-BE49-F238E27FC236}">
-                <a16:creationId xmlns:a16="http://schemas.microsoft.com/office/drawing/2014/main" id="{6F79A9BC-3FAD-46D0-87CE-FD0045F2DB37}"/>
-              </a:ext>
-            </a:extLst>
-          </p:cNvPr>
-          <p:cNvSpPr>
-            <a:spLocks noGrp="1"/>
-          </p:cNvSpPr>
-          <p:nvPr/>
-        </p:nvSpPr>
-        <p:spPr>
-          <a:xfrm>
-            <a:off x="1409700" y="5038725"/>
-            <a:ext cx="4095750" cy="266700"/>
-          </a:xfrm>
-          <a:prstGeom prst="rect">
-            <a:avLst/>
-          </a:prstGeom>
-          <a:noFill/>
-          <a:ln w="0">
-            <a:noFill/>
-          </a:ln>
-        </p:spPr>
-        <p:txBody>
-          <a:bodyPr>
-            <a:normAutofit fontScale="85185"/>
-          </a:bodyPr>
-          <a:lstStyle/>
-          <a:p>
-            <a:pPr algn="l">
-              <a:defRPr sz="1350" b="1">
-                <a:solidFill>
-                  <a:srgbClr val="062D29"/>
-                </a:solidFill>
-                <a:latin typeface="Calibri"/>
-                <a:ea typeface="Calibri"/>
-                <a:cs typeface="Calibri"/>
-              </a:defRPr>
-            </a:pPr>
-            <a:r>
-              <a:rPr sz="1350" b="1">
-                <a:solidFill>
-                  <a:srgbClr val="062D29"/>
-                </a:solidFill>
-                <a:latin typeface="Calibri"/>
-                <a:ea typeface="Calibri"/>
-                <a:cs typeface="Calibri"/>
-              </a:rPr>
-              <a:t>ESG reporting framework</a:t>
-            </a:r>
-          </a:p>
-        </p:txBody>
-      </p:sp>
-      <p:sp>
-        <p:nvSpPr>
-          <p:cNvPr id="24" name="Rettangolo 23">
-            <a:extLst>
-              <a:ext uri="{FF2B5EF4-FFF2-40B4-BE49-F238E27FC236}">
-                <a16:creationId xmlns:a16="http://schemas.microsoft.com/office/drawing/2014/main" id="{A9E6B5D6-FA20-480D-9C55-F4F3402FA17C}"/>
-              </a:ext>
-            </a:extLst>
-          </p:cNvPr>
-          <p:cNvSpPr>
-            <a:spLocks noGrp="1"/>
-          </p:cNvSpPr>
-          <p:nvPr/>
-        </p:nvSpPr>
-        <p:spPr>
-          <a:xfrm>
-            <a:off x="1409700" y="5353050"/>
-            <a:ext cx="4191000" cy="428625"/>
-          </a:xfrm>
-          <a:prstGeom prst="rect">
-            <a:avLst/>
-          </a:prstGeom>
-          <a:noFill/>
-          <a:ln w="0">
-            <a:noFill/>
-          </a:ln>
-        </p:spPr>
-        <p:txBody>
-          <a:bodyPr>
-            <a:normAutofit/>
-          </a:bodyPr>
-          <a:lstStyle/>
-          <a:p>
-            <a:pPr algn="l">
-              <a:defRPr sz="1050" b="0">
-                <a:solidFill>
-                  <a:srgbClr val="4F6E67"/>
-                </a:solidFill>
-                <a:latin typeface="Calibri"/>
-                <a:ea typeface="Calibri"/>
-                <a:cs typeface="Calibri"/>
-              </a:defRPr>
-            </a:pPr>
-            <a:r>
-              <a:rPr sz="1050" b="0">
-                <a:solidFill>
-                  <a:srgbClr val="4F6E67"/>
-                </a:solidFill>
-                <a:latin typeface="Calibri"/>
-                <a:ea typeface="Calibri"/>
-                <a:cs typeface="Calibri"/>
-              </a:rPr>
-              <a:t>Sono già in uso più framework; TCFD risulta di interesse e richiede dati coerenti.</a:t>
-            </a:r>
-          </a:p>
-        </p:txBody>
-      </p:sp>
-      <p:sp>
-        <p:nvSpPr>
-          <p:cNvPr id="25" name="Rettangolo con angoli arrotondati 24">
-            <a:extLst>
-              <a:ext uri="{FF2B5EF4-FFF2-40B4-BE49-F238E27FC236}">
-                <a16:creationId xmlns:a16="http://schemas.microsoft.com/office/drawing/2014/main" id="{E867D57D-9D7B-49EB-BBCD-E8B8EF2CBDD7}"/>
-              </a:ext>
-            </a:extLst>
-          </p:cNvPr>
-          <p:cNvSpPr>
-            <a:spLocks noGrp="1"/>
-          </p:cNvSpPr>
-          <p:nvPr/>
-        </p:nvSpPr>
-        <p:spPr>
-          <a:xfrm>
-            <a:off x="6229350" y="1219200"/>
-            <a:ext cx="5448300" cy="1028700"/>
-          </a:xfrm>
-          <a:prstGeom prst="roundRect">
-            <a:avLst>
-              <a:gd name="adj" fmla="val 12963"/>
-            </a:avLst>
-          </a:prstGeom>
-          <a:solidFill>
-            <a:srgbClr val="FFFFFF"/>
-          </a:solidFill>
-          <a:ln w="9525">
-            <a:solidFill>
-              <a:srgbClr val="C8DBD5"/>
-            </a:solidFill>
-          </a:ln>
-        </p:spPr>
-        <p:txBody>
-          <a:bodyPr/>
-          <a:lstStyle/>
-          <a:p>
-            <a:endParaRPr lang="it-IT"/>
-          </a:p>
-        </p:txBody>
-      </p:sp>
-      <p:sp>
-        <p:nvSpPr>
-          <p:cNvPr id="26" name="Ovale 25">
-            <a:extLst>
-              <a:ext uri="{FF2B5EF4-FFF2-40B4-BE49-F238E27FC236}">
-                <a16:creationId xmlns:a16="http://schemas.microsoft.com/office/drawing/2014/main" id="{E46A9994-528B-44A1-817C-58E1E35BEAAA}"/>
-              </a:ext>
-            </a:extLst>
-          </p:cNvPr>
-          <p:cNvSpPr>
-            <a:spLocks noGrp="1"/>
-          </p:cNvSpPr>
-          <p:nvPr/>
-        </p:nvSpPr>
-        <p:spPr>
-          <a:xfrm>
-            <a:off x="6419850" y="1438275"/>
-            <a:ext cx="514350" cy="514350"/>
-          </a:xfrm>
-          <a:prstGeom prst="ellipse">
-            <a:avLst/>
-          </a:prstGeom>
-          <a:solidFill>
-            <a:srgbClr val="D39A24"/>
-          </a:solidFill>
-          <a:ln w="0">
-            <a:solidFill>
-              <a:srgbClr val="D39A24"/>
-            </a:solidFill>
-          </a:ln>
-        </p:spPr>
-        <p:txBody>
-          <a:bodyPr/>
-          <a:lstStyle/>
-          <a:p>
-            <a:endParaRPr lang="it-IT"/>
-          </a:p>
-        </p:txBody>
-      </p:sp>
-      <p:sp>
-        <p:nvSpPr>
-          <p:cNvPr id="27" name="Rettangolo 26">
-            <a:extLst>
-              <a:ext uri="{FF2B5EF4-FFF2-40B4-BE49-F238E27FC236}">
-                <a16:creationId xmlns:a16="http://schemas.microsoft.com/office/drawing/2014/main" id="{87BACA93-9F25-49BE-BC25-B7E26CF43E10}"/>
-              </a:ext>
-            </a:extLst>
-          </p:cNvPr>
-          <p:cNvSpPr>
-            <a:spLocks noGrp="1"/>
-          </p:cNvSpPr>
-          <p:nvPr/>
-        </p:nvSpPr>
-        <p:spPr>
-          <a:xfrm>
-            <a:off x="6486525" y="1552575"/>
-            <a:ext cx="381000" cy="238125"/>
-          </a:xfrm>
-          <a:prstGeom prst="rect">
-            <a:avLst/>
-          </a:prstGeom>
-          <a:noFill/>
-          <a:ln w="0">
-            <a:noFill/>
-          </a:ln>
-        </p:spPr>
-        <p:txBody>
-          <a:bodyPr>
-            <a:normAutofit fontScale="80208"/>
-          </a:bodyPr>
-          <a:lstStyle/>
-          <a:p>
-            <a:pPr algn="ctr">
-              <a:defRPr sz="1200" b="1">
-                <a:solidFill>
-                  <a:srgbClr val="FFFFFF"/>
-                </a:solidFill>
-                <a:latin typeface="Calibri"/>
-                <a:ea typeface="Calibri"/>
-                <a:cs typeface="Calibri"/>
-              </a:defRPr>
-            </a:pPr>
-            <a:r>
-              <a:rPr sz="1200" b="1">
-                <a:solidFill>
-                  <a:srgbClr val="FFFFFF"/>
-                </a:solidFill>
-                <a:latin typeface="Calibri"/>
-                <a:ea typeface="Calibri"/>
-                <a:cs typeface="Calibri"/>
-              </a:rPr>
-              <a:t>05</a:t>
-            </a:r>
-          </a:p>
-        </p:txBody>
-      </p:sp>
-      <p:sp>
-        <p:nvSpPr>
-          <p:cNvPr id="28" name="Rettangolo 27">
-            <a:extLst>
-              <a:ext uri="{FF2B5EF4-FFF2-40B4-BE49-F238E27FC236}">
-                <a16:creationId xmlns:a16="http://schemas.microsoft.com/office/drawing/2014/main" id="{69A91FC8-EFEA-4258-BAD1-37654FAC4BC7}"/>
-              </a:ext>
-            </a:extLst>
-          </p:cNvPr>
-          <p:cNvSpPr>
-            <a:spLocks noGrp="1"/>
-          </p:cNvSpPr>
-          <p:nvPr/>
-        </p:nvSpPr>
-        <p:spPr>
-          <a:xfrm>
-            <a:off x="7124700" y="1381125"/>
-            <a:ext cx="4095750" cy="266700"/>
-          </a:xfrm>
-          <a:prstGeom prst="rect">
-            <a:avLst/>
-          </a:prstGeom>
-          <a:noFill/>
-          <a:ln w="0">
-            <a:noFill/>
-          </a:ln>
-        </p:spPr>
-        <p:txBody>
-          <a:bodyPr>
-            <a:normAutofit fontScale="85185"/>
-          </a:bodyPr>
-          <a:lstStyle/>
-          <a:p>
-            <a:pPr algn="l">
-              <a:defRPr sz="1350" b="1">
-                <a:solidFill>
-                  <a:srgbClr val="062D29"/>
-                </a:solidFill>
-                <a:latin typeface="Calibri"/>
-                <a:ea typeface="Calibri"/>
-                <a:cs typeface="Calibri"/>
-              </a:defRPr>
-            </a:pPr>
-            <a:r>
-              <a:rPr sz="1350" b="1">
-                <a:solidFill>
-                  <a:srgbClr val="062D29"/>
-                </a:solidFill>
-                <a:latin typeface="Calibri"/>
-                <a:ea typeface="Calibri"/>
-                <a:cs typeface="Calibri"/>
-              </a:rPr>
-              <a:t>Supply chain</a:t>
-            </a:r>
-          </a:p>
-        </p:txBody>
-      </p:sp>
-      <p:sp>
-        <p:nvSpPr>
-          <p:cNvPr id="29" name="Rettangolo 28">
-            <a:extLst>
-              <a:ext uri="{FF2B5EF4-FFF2-40B4-BE49-F238E27FC236}">
-                <a16:creationId xmlns:a16="http://schemas.microsoft.com/office/drawing/2014/main" id="{97DAB211-5FE0-419A-B6AA-8A07F6DDF5E3}"/>
-              </a:ext>
-            </a:extLst>
-          </p:cNvPr>
-          <p:cNvSpPr>
-            <a:spLocks noGrp="1"/>
-          </p:cNvSpPr>
-          <p:nvPr/>
-        </p:nvSpPr>
-        <p:spPr>
-          <a:xfrm>
-            <a:off x="7124700" y="1695450"/>
-            <a:ext cx="4191000" cy="428625"/>
-          </a:xfrm>
-          <a:prstGeom prst="rect">
-            <a:avLst/>
-          </a:prstGeom>
-          <a:noFill/>
-          <a:ln w="0">
-            <a:noFill/>
-          </a:ln>
-        </p:spPr>
-        <p:txBody>
-          <a:bodyPr>
-            <a:normAutofit/>
-          </a:bodyPr>
-          <a:lstStyle/>
-          <a:p>
-            <a:pPr algn="l">
-              <a:defRPr sz="1050" b="0">
-                <a:solidFill>
-                  <a:srgbClr val="4F6E67"/>
-                </a:solidFill>
-                <a:latin typeface="Calibri"/>
-                <a:ea typeface="Calibri"/>
-                <a:cs typeface="Calibri"/>
-              </a:defRPr>
-            </a:pPr>
-            <a:r>
-              <a:rPr sz="1050" b="0">
-                <a:solidFill>
-                  <a:srgbClr val="4F6E67"/>
-                </a:solidFill>
-                <a:latin typeface="Calibri"/>
-                <a:ea typeface="Calibri"/>
-                <a:cs typeface="Calibri"/>
-              </a:rPr>
-              <a:t>I fornitori inviano PDF e allegati non strutturati, difficili da riconciliare.</a:t>
-            </a:r>
-          </a:p>
-        </p:txBody>
-      </p:sp>
-      <p:sp>
-        <p:nvSpPr>
-          <p:cNvPr id="30" name="Rettangolo con angoli arrotondati 29">
-            <a:extLst>
-              <a:ext uri="{FF2B5EF4-FFF2-40B4-BE49-F238E27FC236}">
-                <a16:creationId xmlns:a16="http://schemas.microsoft.com/office/drawing/2014/main" id="{F24512A5-1266-4FB8-8C3F-6A86E50FFD6C}"/>
-              </a:ext>
-            </a:extLst>
-          </p:cNvPr>
-          <p:cNvSpPr>
-            <a:spLocks noGrp="1"/>
-          </p:cNvSpPr>
-          <p:nvPr/>
-        </p:nvSpPr>
-        <p:spPr>
-          <a:xfrm>
-            <a:off x="6229350" y="2438400"/>
-            <a:ext cx="5448300" cy="1028700"/>
-          </a:xfrm>
-          <a:prstGeom prst="roundRect">
-            <a:avLst>
-              <a:gd name="adj" fmla="val 12963"/>
-            </a:avLst>
-          </a:prstGeom>
-          <a:solidFill>
-            <a:srgbClr val="FFFFFF"/>
-          </a:solidFill>
-          <a:ln w="9525">
-            <a:solidFill>
-              <a:srgbClr val="C8DBD5"/>
-            </a:solidFill>
-          </a:ln>
-        </p:spPr>
-        <p:txBody>
-          <a:bodyPr/>
-          <a:lstStyle/>
-          <a:p>
-            <a:endParaRPr lang="it-IT"/>
-          </a:p>
-        </p:txBody>
-      </p:sp>
-      <p:sp>
-        <p:nvSpPr>
-          <p:cNvPr id="31" name="Ovale 30">
-            <a:extLst>
-              <a:ext uri="{FF2B5EF4-FFF2-40B4-BE49-F238E27FC236}">
-                <a16:creationId xmlns:a16="http://schemas.microsoft.com/office/drawing/2014/main" id="{DF315A0C-FBBE-42A3-9508-09242B09EAC6}"/>
-              </a:ext>
-            </a:extLst>
-          </p:cNvPr>
-          <p:cNvSpPr>
-            <a:spLocks noGrp="1"/>
-          </p:cNvSpPr>
-          <p:nvPr/>
-        </p:nvSpPr>
-        <p:spPr>
-          <a:xfrm>
-            <a:off x="6419850" y="2657475"/>
-            <a:ext cx="514350" cy="514350"/>
-          </a:xfrm>
-          <a:prstGeom prst="ellipse">
-            <a:avLst/>
-          </a:prstGeom>
-          <a:solidFill>
-            <a:srgbClr val="5CA87B"/>
-          </a:solidFill>
-          <a:ln w="0">
-            <a:solidFill>
-              <a:srgbClr val="5CA87B"/>
-            </a:solidFill>
-          </a:ln>
-        </p:spPr>
-        <p:txBody>
-          <a:bodyPr/>
-          <a:lstStyle/>
-          <a:p>
-            <a:endParaRPr lang="it-IT"/>
-          </a:p>
-        </p:txBody>
-      </p:sp>
-      <p:sp>
-        <p:nvSpPr>
-          <p:cNvPr id="32" name="Rettangolo 31">
-            <a:extLst>
-              <a:ext uri="{FF2B5EF4-FFF2-40B4-BE49-F238E27FC236}">
-                <a16:creationId xmlns:a16="http://schemas.microsoft.com/office/drawing/2014/main" id="{AB72AC1C-22E7-457F-A3EF-4525FE7C4A41}"/>
-              </a:ext>
-            </a:extLst>
-          </p:cNvPr>
-          <p:cNvSpPr>
-            <a:spLocks noGrp="1"/>
-          </p:cNvSpPr>
-          <p:nvPr/>
-        </p:nvSpPr>
-        <p:spPr>
-          <a:xfrm>
-            <a:off x="6486525" y="2771775"/>
-            <a:ext cx="381000" cy="238125"/>
-          </a:xfrm>
-          <a:prstGeom prst="rect">
-            <a:avLst/>
-          </a:prstGeom>
-          <a:noFill/>
-          <a:ln w="0">
-            <a:noFill/>
-          </a:ln>
-        </p:spPr>
-        <p:txBody>
-          <a:bodyPr>
-            <a:normAutofit fontScale="80208"/>
-          </a:bodyPr>
-          <a:lstStyle/>
-          <a:p>
-            <a:pPr algn="ctr">
-              <a:defRPr sz="1200" b="1">
-                <a:solidFill>
-                  <a:srgbClr val="FFFFFF"/>
-                </a:solidFill>
-                <a:latin typeface="Calibri"/>
-                <a:ea typeface="Calibri"/>
-                <a:cs typeface="Calibri"/>
-              </a:defRPr>
-            </a:pPr>
-            <a:r>
-              <a:rPr sz="1200" b="1">
-                <a:solidFill>
-                  <a:srgbClr val="FFFFFF"/>
-                </a:solidFill>
-                <a:latin typeface="Calibri"/>
-                <a:ea typeface="Calibri"/>
-                <a:cs typeface="Calibri"/>
-              </a:rPr>
-              <a:t>06</a:t>
-            </a:r>
-          </a:p>
-        </p:txBody>
-      </p:sp>
-      <p:sp>
-        <p:nvSpPr>
-          <p:cNvPr id="33" name="Rettangolo 32">
-            <a:extLst>
-              <a:ext uri="{FF2B5EF4-FFF2-40B4-BE49-F238E27FC236}">
-                <a16:creationId xmlns:a16="http://schemas.microsoft.com/office/drawing/2014/main" id="{2E8C5641-E3CF-4888-8DF6-06163FB89BB2}"/>
-              </a:ext>
-            </a:extLst>
-          </p:cNvPr>
-          <p:cNvSpPr>
-            <a:spLocks noGrp="1"/>
-          </p:cNvSpPr>
-          <p:nvPr/>
-        </p:nvSpPr>
-        <p:spPr>
-          <a:xfrm>
-            <a:off x="7124700" y="2600325"/>
-            <a:ext cx="4095750" cy="266700"/>
-          </a:xfrm>
-          <a:prstGeom prst="rect">
-            <a:avLst/>
-          </a:prstGeom>
-          <a:noFill/>
-          <a:ln w="0">
-            <a:noFill/>
-          </a:ln>
-        </p:spPr>
-        <p:txBody>
-          <a:bodyPr>
-            <a:normAutofit fontScale="85185"/>
-          </a:bodyPr>
-          <a:lstStyle/>
-          <a:p>
-            <a:pPr algn="l">
-              <a:defRPr sz="1350" b="1">
-                <a:solidFill>
-                  <a:srgbClr val="062D29"/>
-                </a:solidFill>
-                <a:latin typeface="Calibri"/>
-                <a:ea typeface="Calibri"/>
-                <a:cs typeface="Calibri"/>
-              </a:defRPr>
-            </a:pPr>
-            <a:r>
-              <a:rPr sz="1350" b="1">
-                <a:solidFill>
-                  <a:srgbClr val="062D29"/>
-                </a:solidFill>
-                <a:latin typeface="Calibri"/>
-                <a:ea typeface="Calibri"/>
-                <a:cs typeface="Calibri"/>
-              </a:rPr>
-              <a:t>Energia</a:t>
-            </a:r>
-          </a:p>
-        </p:txBody>
-      </p:sp>
-      <p:sp>
-        <p:nvSpPr>
-          <p:cNvPr id="34" name="Rettangolo 33">
-            <a:extLst>
-              <a:ext uri="{FF2B5EF4-FFF2-40B4-BE49-F238E27FC236}">
-                <a16:creationId xmlns:a16="http://schemas.microsoft.com/office/drawing/2014/main" id="{42BE9714-3F31-4DD0-ACB3-554B05DB0E99}"/>
-              </a:ext>
-            </a:extLst>
-          </p:cNvPr>
-          <p:cNvSpPr>
-            <a:spLocks noGrp="1"/>
-          </p:cNvSpPr>
-          <p:nvPr/>
-        </p:nvSpPr>
-        <p:spPr>
-          <a:xfrm>
-            <a:off x="7124700" y="2914650"/>
-            <a:ext cx="4191000" cy="428625"/>
-          </a:xfrm>
-          <a:prstGeom prst="rect">
-            <a:avLst/>
-          </a:prstGeom>
-          <a:noFill/>
-          <a:ln w="0">
-            <a:noFill/>
-          </a:ln>
-        </p:spPr>
-        <p:txBody>
-          <a:bodyPr>
-            <a:normAutofit/>
-          </a:bodyPr>
-          <a:lstStyle/>
-          <a:p>
-            <a:pPr algn="l">
-              <a:defRPr sz="1050" b="0">
-                <a:solidFill>
-                  <a:srgbClr val="4F6E67"/>
-                </a:solidFill>
-                <a:latin typeface="Calibri"/>
-                <a:ea typeface="Calibri"/>
-                <a:cs typeface="Calibri"/>
-              </a:defRPr>
-            </a:pPr>
-            <a:r>
-              <a:rPr sz="1050" b="0">
-                <a:solidFill>
-                  <a:srgbClr val="4F6E67"/>
-                </a:solidFill>
-                <a:latin typeface="Calibri"/>
-                <a:ea typeface="Calibri"/>
-                <a:cs typeface="Calibri"/>
-              </a:rPr>
-              <a:t>Il CFO richiede NPV e payback per iniziativa, partendo da dati energetici verificabili.</a:t>
-            </a:r>
-          </a:p>
-        </p:txBody>
-      </p:sp>
-      <p:sp>
-        <p:nvSpPr>
-          <p:cNvPr id="35" name="Rettangolo con angoli arrotondati 34">
-            <a:extLst>
-              <a:ext uri="{FF2B5EF4-FFF2-40B4-BE49-F238E27FC236}">
-                <a16:creationId xmlns:a16="http://schemas.microsoft.com/office/drawing/2014/main" id="{23CFE4F1-DB8A-467B-98FF-DA571C657988}"/>
-              </a:ext>
-            </a:extLst>
-          </p:cNvPr>
-          <p:cNvSpPr>
-            <a:spLocks noGrp="1"/>
-          </p:cNvSpPr>
-          <p:nvPr/>
-        </p:nvSpPr>
-        <p:spPr>
-          <a:xfrm>
-            <a:off x="6229350" y="3657600"/>
-            <a:ext cx="5448300" cy="1028700"/>
-          </a:xfrm>
-          <a:prstGeom prst="roundRect">
-            <a:avLst>
-              <a:gd name="adj" fmla="val 12963"/>
-            </a:avLst>
-          </a:prstGeom>
-          <a:solidFill>
-            <a:srgbClr val="FFFFFF"/>
-          </a:solidFill>
-          <a:ln w="9525">
-            <a:solidFill>
-              <a:srgbClr val="C8DBD5"/>
-            </a:solidFill>
-          </a:ln>
-        </p:spPr>
-        <p:txBody>
-          <a:bodyPr/>
-          <a:lstStyle/>
-          <a:p>
-            <a:endParaRPr lang="it-IT"/>
-          </a:p>
-        </p:txBody>
-      </p:sp>
-      <p:sp>
-        <p:nvSpPr>
-          <p:cNvPr id="36" name="Ovale 35">
-            <a:extLst>
-              <a:ext uri="{FF2B5EF4-FFF2-40B4-BE49-F238E27FC236}">
-                <a16:creationId xmlns:a16="http://schemas.microsoft.com/office/drawing/2014/main" id="{414A4926-44F0-4F70-A293-15213B0D4B9C}"/>
-              </a:ext>
-            </a:extLst>
-          </p:cNvPr>
-          <p:cNvSpPr>
-            <a:spLocks noGrp="1"/>
-          </p:cNvSpPr>
-          <p:nvPr/>
-        </p:nvSpPr>
-        <p:spPr>
-          <a:xfrm>
-            <a:off x="6419850" y="3876675"/>
-            <a:ext cx="514350" cy="514350"/>
-          </a:xfrm>
-          <a:prstGeom prst="ellipse">
-            <a:avLst/>
-          </a:prstGeom>
-          <a:solidFill>
-            <a:srgbClr val="C75555"/>
-          </a:solidFill>
-          <a:ln w="0">
-            <a:solidFill>
-              <a:srgbClr val="C75555"/>
-            </a:solidFill>
-          </a:ln>
-        </p:spPr>
-        <p:txBody>
-          <a:bodyPr/>
-          <a:lstStyle/>
-          <a:p>
-            <a:endParaRPr lang="it-IT"/>
-          </a:p>
-        </p:txBody>
-      </p:sp>
-      <p:sp>
-        <p:nvSpPr>
-          <p:cNvPr id="37" name="Rettangolo 36">
-            <a:extLst>
-              <a:ext uri="{FF2B5EF4-FFF2-40B4-BE49-F238E27FC236}">
-                <a16:creationId xmlns:a16="http://schemas.microsoft.com/office/drawing/2014/main" id="{F1657348-6DCD-4776-80D1-A0F7A2A2922A}"/>
-              </a:ext>
-            </a:extLst>
-          </p:cNvPr>
-          <p:cNvSpPr>
-            <a:spLocks noGrp="1"/>
-          </p:cNvSpPr>
-          <p:nvPr/>
-        </p:nvSpPr>
-        <p:spPr>
-          <a:xfrm>
-            <a:off x="6486525" y="3990975"/>
-            <a:ext cx="381000" cy="238125"/>
-          </a:xfrm>
-          <a:prstGeom prst="rect">
-            <a:avLst/>
-          </a:prstGeom>
-          <a:noFill/>
-          <a:ln w="0">
-            <a:noFill/>
-          </a:ln>
-        </p:spPr>
-        <p:txBody>
-          <a:bodyPr>
-            <a:normAutofit fontScale="80208"/>
-          </a:bodyPr>
-          <a:lstStyle/>
-          <a:p>
-            <a:pPr algn="ctr">
-              <a:defRPr sz="1200" b="1">
-                <a:solidFill>
-                  <a:srgbClr val="FFFFFF"/>
-                </a:solidFill>
-                <a:latin typeface="Calibri"/>
-                <a:ea typeface="Calibri"/>
-                <a:cs typeface="Calibri"/>
-              </a:defRPr>
-            </a:pPr>
-            <a:r>
-              <a:rPr sz="1200" b="1">
-                <a:solidFill>
-                  <a:srgbClr val="FFFFFF"/>
-                </a:solidFill>
-                <a:latin typeface="Calibri"/>
-                <a:ea typeface="Calibri"/>
-                <a:cs typeface="Calibri"/>
-              </a:rPr>
-              <a:t>07</a:t>
-            </a:r>
-          </a:p>
-        </p:txBody>
-      </p:sp>
-      <p:sp>
-        <p:nvSpPr>
-          <p:cNvPr id="38" name="Rettangolo 37">
-            <a:extLst>
-              <a:ext uri="{FF2B5EF4-FFF2-40B4-BE49-F238E27FC236}">
-                <a16:creationId xmlns:a16="http://schemas.microsoft.com/office/drawing/2014/main" id="{24CF3303-8D49-4A1E-AEC1-36CF981922B5}"/>
-              </a:ext>
-            </a:extLst>
-          </p:cNvPr>
-          <p:cNvSpPr>
-            <a:spLocks noGrp="1"/>
-          </p:cNvSpPr>
-          <p:nvPr/>
-        </p:nvSpPr>
-        <p:spPr>
-          <a:xfrm>
-            <a:off x="7124700" y="3819525"/>
-            <a:ext cx="4095750" cy="266700"/>
-          </a:xfrm>
-          <a:prstGeom prst="rect">
-            <a:avLst/>
-          </a:prstGeom>
-          <a:noFill/>
-          <a:ln w="0">
-            <a:noFill/>
-          </a:ln>
-        </p:spPr>
-        <p:txBody>
-          <a:bodyPr>
-            <a:normAutofit fontScale="85185"/>
-          </a:bodyPr>
-          <a:lstStyle/>
-          <a:p>
-            <a:pPr algn="l">
-              <a:defRPr sz="1350" b="1">
-                <a:solidFill>
-                  <a:srgbClr val="062D29"/>
-                </a:solidFill>
-                <a:latin typeface="Calibri"/>
-                <a:ea typeface="Calibri"/>
-                <a:cs typeface="Calibri"/>
-              </a:defRPr>
-            </a:pPr>
-            <a:r>
-              <a:rPr sz="1350" b="1">
-                <a:solidFill>
-                  <a:srgbClr val="062D29"/>
-                </a:solidFill>
-                <a:latin typeface="Calibri"/>
-                <a:ea typeface="Calibri"/>
-                <a:cs typeface="Calibri"/>
-              </a:rPr>
-              <a:t>Pianificazione</a:t>
-            </a:r>
-          </a:p>
-        </p:txBody>
-      </p:sp>
-      <p:sp>
-        <p:nvSpPr>
-          <p:cNvPr id="39" name="Rettangolo 38">
-            <a:extLst>
-              <a:ext uri="{FF2B5EF4-FFF2-40B4-BE49-F238E27FC236}">
-                <a16:creationId xmlns:a16="http://schemas.microsoft.com/office/drawing/2014/main" id="{3F6946A5-3449-46AE-9F02-D7FF58C3F961}"/>
-              </a:ext>
-            </a:extLst>
-          </p:cNvPr>
-          <p:cNvSpPr>
-            <a:spLocks noGrp="1"/>
-          </p:cNvSpPr>
-          <p:nvPr/>
-        </p:nvSpPr>
-        <p:spPr>
-          <a:xfrm>
-            <a:off x="7124700" y="4133850"/>
-            <a:ext cx="4191000" cy="428625"/>
-          </a:xfrm>
-          <a:prstGeom prst="rect">
-            <a:avLst/>
-          </a:prstGeom>
-          <a:noFill/>
-          <a:ln w="0">
-            <a:noFill/>
-          </a:ln>
-        </p:spPr>
-        <p:txBody>
-          <a:bodyPr>
-            <a:normAutofit/>
-          </a:bodyPr>
-          <a:lstStyle/>
-          <a:p>
-            <a:pPr algn="l">
-              <a:defRPr sz="1050" b="0">
-                <a:solidFill>
-                  <a:srgbClr val="4F6E67"/>
-                </a:solidFill>
-                <a:latin typeface="Calibri"/>
-                <a:ea typeface="Calibri"/>
-                <a:cs typeface="Calibri"/>
-              </a:defRPr>
-            </a:pPr>
-            <a:r>
-              <a:rPr sz="1050" b="0">
-                <a:solidFill>
-                  <a:srgbClr val="4F6E67"/>
-                </a:solidFill>
-                <a:latin typeface="Calibri"/>
-                <a:ea typeface="Calibri"/>
-                <a:cs typeface="Calibri"/>
-              </a:rPr>
-              <a:t>Scenari, traiettorie e impatto degli investimenti risultano altamente rilevanti e critici.</a:t>
-            </a:r>
-          </a:p>
-        </p:txBody>
-      </p:sp>
-      <p:sp>
-        <p:nvSpPr>
-          <p:cNvPr id="40" name="Rettangolo con angoli arrotondati 39">
-            <a:extLst>
-              <a:ext uri="{FF2B5EF4-FFF2-40B4-BE49-F238E27FC236}">
-                <a16:creationId xmlns:a16="http://schemas.microsoft.com/office/drawing/2014/main" id="{9013EAB3-5FE2-4691-8217-757FC71B2B3D}"/>
-              </a:ext>
-            </a:extLst>
-          </p:cNvPr>
-          <p:cNvSpPr>
-            <a:spLocks noGrp="1"/>
-          </p:cNvSpPr>
-          <p:nvPr/>
-        </p:nvSpPr>
-        <p:spPr>
-          <a:xfrm>
-            <a:off x="6229350" y="4953000"/>
-            <a:ext cx="5448300" cy="1143000"/>
-          </a:xfrm>
-          <a:prstGeom prst="roundRect">
-            <a:avLst>
-              <a:gd name="adj" fmla="val 11667"/>
-            </a:avLst>
-          </a:prstGeom>
-          <a:solidFill>
-            <a:srgbClr val="DFF2EA"/>
-          </a:solidFill>
-          <a:ln w="9525">
-            <a:solidFill>
-              <a:srgbClr val="B9D7CC"/>
-            </a:solidFill>
-          </a:ln>
-        </p:spPr>
-        <p:txBody>
-          <a:bodyPr/>
-          <a:lstStyle/>
-          <a:p>
-            <a:endParaRPr lang="it-IT"/>
-          </a:p>
-        </p:txBody>
-      </p:sp>
-      <p:sp>
-        <p:nvSpPr>
-          <p:cNvPr id="41" name="Rettangolo 40">
-            <a:extLst>
-              <a:ext uri="{FF2B5EF4-FFF2-40B4-BE49-F238E27FC236}">
-                <a16:creationId xmlns:a16="http://schemas.microsoft.com/office/drawing/2014/main" id="{ABA7D50D-4236-4C1F-9576-C2AF22C0852A}"/>
-              </a:ext>
-            </a:extLst>
-          </p:cNvPr>
-          <p:cNvSpPr>
-            <a:spLocks noGrp="1"/>
-          </p:cNvSpPr>
-          <p:nvPr/>
-        </p:nvSpPr>
-        <p:spPr>
-          <a:xfrm>
-            <a:off x="6515100" y="5191125"/>
-            <a:ext cx="4857750" cy="666750"/>
-          </a:xfrm>
-          <a:prstGeom prst="rect">
-            <a:avLst/>
-          </a:prstGeom>
-          <a:noFill/>
-          <a:ln w="0">
-            <a:noFill/>
-          </a:ln>
-        </p:spPr>
-        <p:txBody>
-          <a:bodyPr>
-            <a:normAutofit/>
-          </a:bodyPr>
-          <a:lstStyle/>
-          <a:p>
-            <a:pPr algn="l">
-              <a:defRPr sz="1200" b="0">
-                <a:solidFill>
-                  <a:srgbClr val="062D29"/>
-                </a:solidFill>
-                <a:latin typeface="Calibri"/>
-                <a:ea typeface="Calibri"/>
-                <a:cs typeface="Calibri"/>
-              </a:defRPr>
-            </a:pPr>
-            <a:r>
-              <a:rPr sz="1200" b="0">
-                <a:solidFill>
-                  <a:srgbClr val="062D29"/>
-                </a:solidFill>
-                <a:latin typeface="Calibri"/>
-                <a:ea typeface="Calibri"/>
-                <a:cs typeface="Calibri"/>
-              </a:rPr>
-              <a:t>La sequenza e la profondità delle domande cambiano in base a settore, presenza geografica, framework selezionati e maturità dei dati.</a:t>
-            </a:r>
-          </a:p>
-        </p:txBody>
-      </p:sp>
-      <p:sp>
-        <p:nvSpPr>
-          <p:cNvPr id="42" name="Rettangolo 41">
-            <a:extLst>
-              <a:ext uri="{FF2B5EF4-FFF2-40B4-BE49-F238E27FC236}">
-                <a16:creationId xmlns:a16="http://schemas.microsoft.com/office/drawing/2014/main" id="{0EC1376F-B8AD-4A31-9CC4-C7BE475BEBC3}"/>
-              </a:ext>
-            </a:extLst>
-          </p:cNvPr>
-          <p:cNvSpPr>
-            <a:spLocks noGrp="1"/>
-          </p:cNvSpPr>
-          <p:nvPr/>
-        </p:nvSpPr>
-        <p:spPr>
-          <a:xfrm>
-            <a:off x="4810125" y="6534150"/>
-            <a:ext cx="2571750" cy="209550"/>
-          </a:xfrm>
-          <a:prstGeom prst="rect">
-            <a:avLst/>
-          </a:prstGeom>
-          <a:noFill/>
-          <a:ln w="0">
-            <a:noFill/>
-          </a:ln>
-        </p:spPr>
-        <p:txBody>
-          <a:bodyPr>
-            <a:normAutofit fontScale="86111"/>
-          </a:bodyPr>
-          <a:lstStyle/>
-          <a:p>
-            <a:pPr algn="ctr">
-              <a:defRPr sz="900" b="0">
-                <a:solidFill>
-                  <a:srgbClr val="496C66"/>
-                </a:solidFill>
-                <a:latin typeface="Calibri"/>
-                <a:ea typeface="Calibri"/>
-                <a:cs typeface="Calibri"/>
-              </a:defRPr>
-            </a:pPr>
-            <a:r>
-              <a:rPr sz="900" b="0">
-                <a:solidFill>
-                  <a:srgbClr val="496C66"/>
-                </a:solidFill>
-                <a:latin typeface="Calibri"/>
-                <a:ea typeface="Calibri"/>
-                <a:cs typeface="Calibri"/>
-              </a:rPr>
-              <a:t>IBM Envizi Quest</a:t>
-            </a:r>
-          </a:p>
-        </p:txBody>
-      </p:sp>
-    </p:spTree>
-    <p:extLst>
-      <p:ext uri="{BB962C8B-B14F-4D97-AF65-F5344CB8AC3E}">
-        <p14:creationId xmlns:p14="http://schemas.microsoft.com/office/powerpoint/2010/main" val="758405313"/>
-      </p:ext>
-    </p:extLst>
-  </p:cSld>
-  <p:clrMapOvr>
-    <a:masterClrMapping/>
-  </p:clrMapOvr>
-</p:sld>
-</file>
-
 <file path=ppt/theme/theme1.xml><?xml version="1.0" encoding="utf-8"?>
 <a:theme xmlns:a="http://schemas.openxmlformats.org/drawingml/2006/main" name="ChatGPT">
   <a:themeElements>

</xml_diff>